<commit_message>
added top missed locations
</commit_message>
<xml_diff>
--- a/slides_rme.pptx
+++ b/slides_rme.pptx
@@ -11,9 +11,10 @@
     <p:sldId id="257" r:id="rId5"/>
     <p:sldId id="261" r:id="rId6"/>
     <p:sldId id="256" r:id="rId7"/>
-    <p:sldId id="262" r:id="rId8"/>
-    <p:sldId id="263" r:id="rId9"/>
-    <p:sldId id="264" r:id="rId10"/>
+    <p:sldId id="265" r:id="rId8"/>
+    <p:sldId id="262" r:id="rId9"/>
+    <p:sldId id="263" r:id="rId10"/>
+    <p:sldId id="264" r:id="rId11"/>
   </p:sldIdLst>
   <p:sldSz cx="12192000" cy="6858000"/>
   <p:notesSz cx="6858000" cy="9144000"/>
@@ -112,6 +113,11 @@
       </a:defRPr>
     </a:lvl9pPr>
   </p:defaultTextStyle>
+  <p:extLst>
+    <p:ext uri="{EFAFB233-063F-42B5-8137-9DF3F51BA10A}">
+      <p15:sldGuideLst xmlns:p15="http://schemas.microsoft.com/office/powerpoint/2012/main"/>
+    </p:ext>
+  </p:extLst>
 </p:presentation>
 </file>
 
@@ -3400,6 +3406,134 @@
 </p:sld>
 </file>
 
+<file path=ppt/slides/slide10.xml><?xml version="1.0" encoding="utf-8"?>
+<p:sld xmlns:a="http://schemas.openxmlformats.org/drawingml/2006/main" xmlns:r="http://schemas.openxmlformats.org/officeDocument/2006/relationships" xmlns:p="http://schemas.openxmlformats.org/presentationml/2006/main">
+  <p:cSld>
+    <p:spTree>
+      <p:nvGrpSpPr>
+        <p:cNvPr id="1" name=""/>
+        <p:cNvGrpSpPr/>
+        <p:nvPr/>
+      </p:nvGrpSpPr>
+      <p:grpSpPr>
+        <a:xfrm>
+          <a:off x="0" y="0"/>
+          <a:ext cx="0" cy="0"/>
+          <a:chOff x="0" y="0"/>
+          <a:chExt cx="0" cy="0"/>
+        </a:xfrm>
+      </p:grpSpPr>
+      <p:sp>
+        <p:nvSpPr>
+          <p:cNvPr id="2" name="Title 1">
+            <a:extLst>
+              <a:ext uri="{FF2B5EF4-FFF2-40B4-BE49-F238E27FC236}">
+                <a16:creationId xmlns:a16="http://schemas.microsoft.com/office/drawing/2014/main" id="{71AFDFF5-7F16-36C3-CDF5-C31DC89FCA16}"/>
+              </a:ext>
+            </a:extLst>
+          </p:cNvPr>
+          <p:cNvSpPr>
+            <a:spLocks noGrp="1"/>
+          </p:cNvSpPr>
+          <p:nvPr>
+            <p:ph type="title"/>
+          </p:nvPr>
+        </p:nvSpPr>
+        <p:spPr/>
+        <p:txBody>
+          <a:bodyPr/>
+          <a:lstStyle/>
+          <a:p>
+            <a:r>
+              <a:rPr lang="en-US" dirty="0"/>
+              <a:t>Conclusions</a:t>
+            </a:r>
+          </a:p>
+        </p:txBody>
+      </p:sp>
+      <p:sp>
+        <p:nvSpPr>
+          <p:cNvPr id="3" name="Content Placeholder 2">
+            <a:extLst>
+              <a:ext uri="{FF2B5EF4-FFF2-40B4-BE49-F238E27FC236}">
+                <a16:creationId xmlns:a16="http://schemas.microsoft.com/office/drawing/2014/main" id="{078B2F5D-014F-BDDA-ADD1-E7FC12C4B8EE}"/>
+              </a:ext>
+            </a:extLst>
+          </p:cNvPr>
+          <p:cNvSpPr>
+            <a:spLocks noGrp="1"/>
+          </p:cNvSpPr>
+          <p:nvPr>
+            <p:ph idx="1"/>
+          </p:nvPr>
+        </p:nvSpPr>
+        <p:spPr>
+          <a:xfrm>
+            <a:off x="838200" y="1440873"/>
+            <a:ext cx="10515600" cy="4736090"/>
+          </a:xfrm>
+        </p:spPr>
+        <p:txBody>
+          <a:bodyPr>
+            <a:normAutofit fontScale="92500" lnSpcReduction="10000"/>
+          </a:bodyPr>
+          <a:lstStyle/>
+          <a:p>
+            <a:r>
+              <a:rPr lang="en-US" dirty="0"/>
+              <a:t>While the data provided allows us to calculate possible fines to the trash hauling company, it is difficult to make comparisons about their performance for a few reasons:</a:t>
+            </a:r>
+          </a:p>
+          <a:p>
+            <a:pPr marL="914400" lvl="1" indent="-457200">
+              <a:buFont typeface="+mj-lt"/>
+              <a:buAutoNum type="arabicPeriod"/>
+            </a:pPr>
+            <a:r>
+              <a:rPr lang="en-US" dirty="0"/>
+              <a:t>The data is based on complaints reported by residents and may not accurately map to actual missed pickups.</a:t>
+            </a:r>
+          </a:p>
+          <a:p>
+            <a:pPr marL="914400" lvl="1" indent="-457200">
+              <a:buFont typeface="+mj-lt"/>
+              <a:buAutoNum type="arabicPeriod"/>
+            </a:pPr>
+            <a:r>
+              <a:rPr lang="en-US" dirty="0"/>
+              <a:t>Incorporating information about the number of locations each route and company cover would be needed to determine the rate of missed pickups.</a:t>
+            </a:r>
+          </a:p>
+          <a:p>
+            <a:r>
+              <a:rPr lang="en-US" dirty="0"/>
+              <a:t>Further exploration to ensure trash services are available equitably could also look at differences in pickup rates by council districts, average income or home price for a neighborhood, or the day of week that pickup is scheduled for.</a:t>
+            </a:r>
+          </a:p>
+          <a:p>
+            <a:r>
+              <a:rPr lang="en-US" dirty="0"/>
+              <a:t>Finally, there may be differences within the haulers, such as salary or work culture, that impact pick-up rates, rather than details about the pick-up locations.</a:t>
+            </a:r>
+          </a:p>
+          <a:p>
+            <a:endParaRPr lang="en-US" dirty="0"/>
+          </a:p>
+        </p:txBody>
+      </p:sp>
+    </p:spTree>
+    <p:extLst>
+      <p:ext uri="{BB962C8B-B14F-4D97-AF65-F5344CB8AC3E}">
+        <p14:creationId xmlns:p14="http://schemas.microsoft.com/office/powerpoint/2010/main" val="1396121432"/>
+      </p:ext>
+    </p:extLst>
+  </p:cSld>
+  <p:clrMapOvr>
+    <a:masterClrMapping/>
+  </p:clrMapOvr>
+</p:sld>
+</file>
+
 <file path=ppt/slides/slide2.xml><?xml version="1.0" encoding="utf-8"?>
 <p:sld xmlns:a="http://schemas.openxmlformats.org/drawingml/2006/main" xmlns:r="http://schemas.openxmlformats.org/officeDocument/2006/relationships" xmlns:p="http://schemas.openxmlformats.org/presentationml/2006/main">
   <p:cSld>
@@ -4116,6 +4250,521 @@
           <p:cNvPr id="2" name="Title 1">
             <a:extLst>
               <a:ext uri="{FF2B5EF4-FFF2-40B4-BE49-F238E27FC236}">
+                <a16:creationId xmlns:a16="http://schemas.microsoft.com/office/drawing/2014/main" id="{C299EEB6-2F6A-9750-55F0-8D6D5DADEDBC}"/>
+              </a:ext>
+            </a:extLst>
+          </p:cNvPr>
+          <p:cNvSpPr>
+            <a:spLocks noGrp="1"/>
+          </p:cNvSpPr>
+          <p:nvPr>
+            <p:ph type="title"/>
+          </p:nvPr>
+        </p:nvSpPr>
+        <p:spPr/>
+        <p:txBody>
+          <a:bodyPr/>
+          <a:lstStyle/>
+          <a:p>
+            <a:r>
+              <a:rPr lang="en-US" dirty="0"/>
+              <a:t>Frequently Missed Locations</a:t>
+            </a:r>
+          </a:p>
+        </p:txBody>
+      </p:sp>
+      <p:sp>
+        <p:nvSpPr>
+          <p:cNvPr id="10" name="Content Placeholder 9">
+            <a:extLst>
+              <a:ext uri="{FF2B5EF4-FFF2-40B4-BE49-F238E27FC236}">
+                <a16:creationId xmlns:a16="http://schemas.microsoft.com/office/drawing/2014/main" id="{FFF86EDB-2FF2-CDCF-C8DB-632CECCB7820}"/>
+              </a:ext>
+            </a:extLst>
+          </p:cNvPr>
+          <p:cNvSpPr>
+            <a:spLocks noGrp="1"/>
+          </p:cNvSpPr>
+          <p:nvPr>
+            <p:ph sz="half" idx="2"/>
+          </p:nvPr>
+        </p:nvSpPr>
+        <p:spPr>
+          <a:xfrm>
+            <a:off x="6172200" y="3826165"/>
+            <a:ext cx="5181600" cy="1891216"/>
+          </a:xfrm>
+        </p:spPr>
+        <p:txBody>
+          <a:bodyPr>
+            <a:normAutofit fontScale="77500" lnSpcReduction="20000"/>
+          </a:bodyPr>
+          <a:lstStyle/>
+          <a:p>
+            <a:r>
+              <a:rPr lang="en-US" dirty="0"/>
+              <a:t>Old Hickory Blvd is the street with the most missed pickups – over </a:t>
+            </a:r>
+            <a:r>
+              <a:rPr lang="en-US" b="1" dirty="0"/>
+              <a:t>one hundred</a:t>
+            </a:r>
+            <a:r>
+              <a:rPr lang="en-US" dirty="0"/>
+              <a:t> – as well as being the location of the building with the third most misses reported.</a:t>
+            </a:r>
+          </a:p>
+        </p:txBody>
+      </p:sp>
+      <p:graphicFrame>
+        <p:nvGraphicFramePr>
+          <p:cNvPr id="8" name="Content Placeholder 6">
+            <a:extLst>
+              <a:ext uri="{FF2B5EF4-FFF2-40B4-BE49-F238E27FC236}">
+                <a16:creationId xmlns:a16="http://schemas.microsoft.com/office/drawing/2014/main" id="{FF43B930-BED1-1591-2230-212D393F1DAE}"/>
+              </a:ext>
+            </a:extLst>
+          </p:cNvPr>
+          <p:cNvGraphicFramePr>
+            <a:graphicFrameLocks/>
+          </p:cNvGraphicFramePr>
+          <p:nvPr>
+            <p:extLst>
+              <p:ext uri="{D42A27DB-BD31-4B8C-83A1-F6EECF244321}">
+                <p14:modId xmlns:p14="http://schemas.microsoft.com/office/powerpoint/2010/main" val="3222103550"/>
+              </p:ext>
+            </p:extLst>
+          </p:nvPr>
+        </p:nvGraphicFramePr>
+        <p:xfrm>
+          <a:off x="6172200" y="2084243"/>
+          <a:ext cx="5181600" cy="1603375"/>
+        </p:xfrm>
+        <a:graphic>
+          <a:graphicData uri="http://schemas.openxmlformats.org/drawingml/2006/table">
+            <a:tbl>
+              <a:tblPr>
+                <a:tableStyleId>{21E4AEA4-8DFA-4A89-87EB-49C32662AFE0}</a:tableStyleId>
+              </a:tblPr>
+              <a:tblGrid>
+                <a:gridCol w="2590800">
+                  <a:extLst>
+                    <a:ext uri="{9D8B030D-6E8A-4147-A177-3AD203B41FA5}">
+                      <a16:colId xmlns:a16="http://schemas.microsoft.com/office/drawing/2014/main" val="1079851969"/>
+                    </a:ext>
+                  </a:extLst>
+                </a:gridCol>
+                <a:gridCol w="2590800">
+                  <a:extLst>
+                    <a:ext uri="{9D8B030D-6E8A-4147-A177-3AD203B41FA5}">
+                      <a16:colId xmlns:a16="http://schemas.microsoft.com/office/drawing/2014/main" val="275346561"/>
+                    </a:ext>
+                  </a:extLst>
+                </a:gridCol>
+              </a:tblGrid>
+              <a:tr h="332563">
+                <a:tc>
+                  <a:txBody>
+                    <a:bodyPr/>
+                    <a:lstStyle/>
+                    <a:p>
+                      <a:pPr>
+                        <a:buNone/>
+                      </a:pPr>
+                      <a:r>
+                        <a:rPr lang="en-US" sz="1100" b="1" dirty="0"/>
+                        <a:t>Street</a:t>
+                      </a:r>
+                    </a:p>
+                  </a:txBody>
+                  <a:tcPr marL="45057" marR="45057" marT="22529" marB="22529" anchor="ctr"/>
+                </a:tc>
+                <a:tc>
+                  <a:txBody>
+                    <a:bodyPr/>
+                    <a:lstStyle/>
+                    <a:p>
+                      <a:r>
+                        <a:rPr lang="en-US" sz="1100" b="1" dirty="0"/>
+                        <a:t>Missed Pickups</a:t>
+                      </a:r>
+                    </a:p>
+                  </a:txBody>
+                  <a:tcPr marL="45057" marR="45057" marT="22529" marB="22529" anchor="ctr"/>
+                </a:tc>
+                <a:extLst>
+                  <a:ext uri="{0D108BD9-81ED-4DB2-BD59-A6C34878D82A}">
+                    <a16:rowId xmlns:a16="http://schemas.microsoft.com/office/drawing/2014/main" val="2834163256"/>
+                  </a:ext>
+                </a:extLst>
+              </a:tr>
+              <a:tr h="220906">
+                <a:tc>
+                  <a:txBody>
+                    <a:bodyPr/>
+                    <a:lstStyle/>
+                    <a:p>
+                      <a:pPr>
+                        <a:buNone/>
+                      </a:pPr>
+                      <a:r>
+                        <a:rPr lang="nb-NO" sz="1100" dirty="0"/>
+                        <a:t>Old Hickory Blvd</a:t>
+                      </a:r>
+                    </a:p>
+                  </a:txBody>
+                  <a:tcPr marL="45057" marR="45057" marT="22529" marB="22529" anchor="ctr">
+                    <a:solidFill>
+                      <a:schemeClr val="bg1">
+                        <a:lumMod val="95000"/>
+                      </a:schemeClr>
+                    </a:solidFill>
+                  </a:tcPr>
+                </a:tc>
+                <a:tc>
+                  <a:txBody>
+                    <a:bodyPr/>
+                    <a:lstStyle/>
+                    <a:p>
+                      <a:pPr>
+                        <a:buNone/>
+                      </a:pPr>
+                      <a:r>
+                        <a:rPr lang="en-US" sz="1100" dirty="0"/>
+                        <a:t>103</a:t>
+                      </a:r>
+                    </a:p>
+                  </a:txBody>
+                  <a:tcPr marL="45057" marR="45057" marT="22529" marB="22529" anchor="ctr">
+                    <a:solidFill>
+                      <a:schemeClr val="bg1">
+                        <a:lumMod val="95000"/>
+                      </a:schemeClr>
+                    </a:solidFill>
+                  </a:tcPr>
+                </a:tc>
+                <a:extLst>
+                  <a:ext uri="{0D108BD9-81ED-4DB2-BD59-A6C34878D82A}">
+                    <a16:rowId xmlns:a16="http://schemas.microsoft.com/office/drawing/2014/main" val="1848436159"/>
+                  </a:ext>
+                </a:extLst>
+              </a:tr>
+              <a:tr h="387188">
+                <a:tc>
+                  <a:txBody>
+                    <a:bodyPr/>
+                    <a:lstStyle/>
+                    <a:p>
+                      <a:pPr>
+                        <a:buNone/>
+                      </a:pPr>
+                      <a:r>
+                        <a:rPr lang="en-US" sz="1100" dirty="0"/>
+                        <a:t>Buena Vista Pike</a:t>
+                      </a:r>
+                    </a:p>
+                  </a:txBody>
+                  <a:tcPr marL="45057" marR="45057" marT="22529" marB="22529" anchor="ctr">
+                    <a:solidFill>
+                      <a:schemeClr val="bg1">
+                        <a:lumMod val="95000"/>
+                      </a:schemeClr>
+                    </a:solidFill>
+                  </a:tcPr>
+                </a:tc>
+                <a:tc>
+                  <a:txBody>
+                    <a:bodyPr/>
+                    <a:lstStyle/>
+                    <a:p>
+                      <a:pPr>
+                        <a:buNone/>
+                      </a:pPr>
+                      <a:r>
+                        <a:rPr lang="en-US" sz="1100" dirty="0"/>
+                        <a:t>92</a:t>
+                      </a:r>
+                    </a:p>
+                  </a:txBody>
+                  <a:tcPr marL="45057" marR="45057" marT="22529" marB="22529" anchor="ctr">
+                    <a:solidFill>
+                      <a:schemeClr val="bg1">
+                        <a:lumMod val="95000"/>
+                      </a:schemeClr>
+                    </a:solidFill>
+                  </a:tcPr>
+                </a:tc>
+                <a:extLst>
+                  <a:ext uri="{0D108BD9-81ED-4DB2-BD59-A6C34878D82A}">
+                    <a16:rowId xmlns:a16="http://schemas.microsoft.com/office/drawing/2014/main" val="605106746"/>
+                  </a:ext>
+                </a:extLst>
+              </a:tr>
+              <a:tr h="220906">
+                <a:tc>
+                  <a:txBody>
+                    <a:bodyPr/>
+                    <a:lstStyle/>
+                    <a:p>
+                      <a:pPr>
+                        <a:buNone/>
+                      </a:pPr>
+                      <a:r>
+                        <a:rPr lang="en-US" sz="1100" dirty="0"/>
+                        <a:t>Harding Pl</a:t>
+                      </a:r>
+                    </a:p>
+                  </a:txBody>
+                  <a:tcPr marL="45057" marR="45057" marT="22529" marB="22529" anchor="ctr">
+                    <a:solidFill>
+                      <a:schemeClr val="bg1">
+                        <a:lumMod val="95000"/>
+                      </a:schemeClr>
+                    </a:solidFill>
+                  </a:tcPr>
+                </a:tc>
+                <a:tc>
+                  <a:txBody>
+                    <a:bodyPr/>
+                    <a:lstStyle/>
+                    <a:p>
+                      <a:pPr>
+                        <a:buNone/>
+                      </a:pPr>
+                      <a:r>
+                        <a:rPr lang="en-US" sz="1100" dirty="0"/>
+                        <a:t>89</a:t>
+                      </a:r>
+                    </a:p>
+                  </a:txBody>
+                  <a:tcPr marL="45057" marR="45057" marT="22529" marB="22529" anchor="ctr">
+                    <a:solidFill>
+                      <a:schemeClr val="bg1">
+                        <a:lumMod val="95000"/>
+                      </a:schemeClr>
+                    </a:solidFill>
+                  </a:tcPr>
+                </a:tc>
+                <a:extLst>
+                  <a:ext uri="{0D108BD9-81ED-4DB2-BD59-A6C34878D82A}">
+                    <a16:rowId xmlns:a16="http://schemas.microsoft.com/office/drawing/2014/main" val="2717502932"/>
+                  </a:ext>
+                </a:extLst>
+              </a:tr>
+              <a:tr h="220906">
+                <a:tc>
+                  <a:txBody>
+                    <a:bodyPr/>
+                    <a:lstStyle/>
+                    <a:p>
+                      <a:pPr>
+                        <a:buNone/>
+                      </a:pPr>
+                      <a:r>
+                        <a:rPr lang="en-US" sz="1100" dirty="0"/>
+                        <a:t>Granny White Pike</a:t>
+                      </a:r>
+                    </a:p>
+                  </a:txBody>
+                  <a:tcPr marL="45057" marR="45057" marT="22529" marB="22529" anchor="ctr">
+                    <a:solidFill>
+                      <a:schemeClr val="bg1">
+                        <a:lumMod val="95000"/>
+                      </a:schemeClr>
+                    </a:solidFill>
+                  </a:tcPr>
+                </a:tc>
+                <a:tc>
+                  <a:txBody>
+                    <a:bodyPr/>
+                    <a:lstStyle/>
+                    <a:p>
+                      <a:pPr>
+                        <a:buNone/>
+                      </a:pPr>
+                      <a:r>
+                        <a:rPr lang="en-US" sz="1100" dirty="0"/>
+                        <a:t>80</a:t>
+                      </a:r>
+                    </a:p>
+                  </a:txBody>
+                  <a:tcPr marL="45057" marR="45057" marT="22529" marB="22529" anchor="ctr">
+                    <a:solidFill>
+                      <a:schemeClr val="bg1">
+                        <a:lumMod val="95000"/>
+                      </a:schemeClr>
+                    </a:solidFill>
+                  </a:tcPr>
+                </a:tc>
+                <a:extLst>
+                  <a:ext uri="{0D108BD9-81ED-4DB2-BD59-A6C34878D82A}">
+                    <a16:rowId xmlns:a16="http://schemas.microsoft.com/office/drawing/2014/main" val="1854458785"/>
+                  </a:ext>
+                </a:extLst>
+              </a:tr>
+              <a:tr h="220906">
+                <a:tc>
+                  <a:txBody>
+                    <a:bodyPr/>
+                    <a:lstStyle/>
+                    <a:p>
+                      <a:pPr>
+                        <a:buNone/>
+                      </a:pPr>
+                      <a:r>
+                        <a:rPr lang="en-US" sz="1100" dirty="0"/>
+                        <a:t>Clarksville Pike</a:t>
+                      </a:r>
+                    </a:p>
+                  </a:txBody>
+                  <a:tcPr marL="45057" marR="45057" marT="22529" marB="22529" anchor="ctr">
+                    <a:solidFill>
+                      <a:schemeClr val="bg1">
+                        <a:lumMod val="95000"/>
+                      </a:schemeClr>
+                    </a:solidFill>
+                  </a:tcPr>
+                </a:tc>
+                <a:tc>
+                  <a:txBody>
+                    <a:bodyPr/>
+                    <a:lstStyle/>
+                    <a:p>
+                      <a:pPr>
+                        <a:buNone/>
+                      </a:pPr>
+                      <a:r>
+                        <a:rPr lang="en-US" sz="1100" dirty="0"/>
+                        <a:t>63</a:t>
+                      </a:r>
+                    </a:p>
+                  </a:txBody>
+                  <a:tcPr marL="45057" marR="45057" marT="22529" marB="22529" anchor="ctr">
+                    <a:solidFill>
+                      <a:schemeClr val="bg1">
+                        <a:lumMod val="95000"/>
+                      </a:schemeClr>
+                    </a:solidFill>
+                  </a:tcPr>
+                </a:tc>
+                <a:extLst>
+                  <a:ext uri="{0D108BD9-81ED-4DB2-BD59-A6C34878D82A}">
+                    <a16:rowId xmlns:a16="http://schemas.microsoft.com/office/drawing/2014/main" val="109648940"/>
+                  </a:ext>
+                </a:extLst>
+              </a:tr>
+            </a:tbl>
+          </a:graphicData>
+        </a:graphic>
+      </p:graphicFrame>
+      <p:sp>
+        <p:nvSpPr>
+          <p:cNvPr id="12" name="Content Placeholder 11">
+            <a:extLst>
+              <a:ext uri="{FF2B5EF4-FFF2-40B4-BE49-F238E27FC236}">
+                <a16:creationId xmlns:a16="http://schemas.microsoft.com/office/drawing/2014/main" id="{1A3C3846-FE00-1FD9-B4A7-E53C1008A71C}"/>
+              </a:ext>
+            </a:extLst>
+          </p:cNvPr>
+          <p:cNvSpPr>
+            <a:spLocks noGrp="1"/>
+          </p:cNvSpPr>
+          <p:nvPr>
+            <p:ph sz="half" idx="1"/>
+          </p:nvPr>
+        </p:nvSpPr>
+        <p:spPr>
+          <a:xfrm>
+            <a:off x="838201" y="5054599"/>
+            <a:ext cx="5181600" cy="1325564"/>
+          </a:xfrm>
+        </p:spPr>
+        <p:txBody>
+          <a:bodyPr>
+            <a:normAutofit fontScale="77500" lnSpcReduction="20000"/>
+          </a:bodyPr>
+          <a:lstStyle/>
+          <a:p>
+            <a:r>
+              <a:rPr lang="en-US" dirty="0"/>
+              <a:t>While most addresses report missed pickups less than three times, the top-missed addresses have reported missed pickups on over </a:t>
+            </a:r>
+            <a:r>
+              <a:rPr lang="en-US" b="1" dirty="0"/>
+              <a:t>20</a:t>
+            </a:r>
+            <a:r>
+              <a:rPr lang="en-US" dirty="0"/>
+              <a:t> different dates!</a:t>
+            </a:r>
+          </a:p>
+        </p:txBody>
+      </p:sp>
+      <p:pic>
+        <p:nvPicPr>
+          <p:cNvPr id="4" name="Picture 3">
+            <a:extLst>
+              <a:ext uri="{FF2B5EF4-FFF2-40B4-BE49-F238E27FC236}">
+                <a16:creationId xmlns:a16="http://schemas.microsoft.com/office/drawing/2014/main" id="{50BA1C90-AA84-4E94-FFFA-4C2F6713D20A}"/>
+              </a:ext>
+            </a:extLst>
+          </p:cNvPr>
+          <p:cNvPicPr>
+            <a:picLocks noChangeAspect="1"/>
+          </p:cNvPicPr>
+          <p:nvPr/>
+        </p:nvPicPr>
+        <p:blipFill>
+          <a:blip r:embed="rId2"/>
+          <a:stretch>
+            <a:fillRect/>
+          </a:stretch>
+        </p:blipFill>
+        <p:spPr>
+          <a:xfrm>
+            <a:off x="1294447" y="1505715"/>
+            <a:ext cx="3757843" cy="3364735"/>
+          </a:xfrm>
+          <a:prstGeom prst="rect">
+            <a:avLst/>
+          </a:prstGeom>
+        </p:spPr>
+      </p:pic>
+    </p:spTree>
+    <p:extLst>
+      <p:ext uri="{BB962C8B-B14F-4D97-AF65-F5344CB8AC3E}">
+        <p14:creationId xmlns:p14="http://schemas.microsoft.com/office/powerpoint/2010/main" val="1300224343"/>
+      </p:ext>
+    </p:extLst>
+  </p:cSld>
+  <p:clrMapOvr>
+    <a:masterClrMapping/>
+  </p:clrMapOvr>
+</p:sld>
+</file>
+
+<file path=ppt/slides/slide8.xml><?xml version="1.0" encoding="utf-8"?>
+<p:sld xmlns:a="http://schemas.openxmlformats.org/drawingml/2006/main" xmlns:r="http://schemas.openxmlformats.org/officeDocument/2006/relationships" xmlns:p="http://schemas.openxmlformats.org/presentationml/2006/main">
+  <p:cSld>
+    <p:spTree>
+      <p:nvGrpSpPr>
+        <p:cNvPr id="1" name=""/>
+        <p:cNvGrpSpPr/>
+        <p:nvPr/>
+      </p:nvGrpSpPr>
+      <p:grpSpPr>
+        <a:xfrm>
+          <a:off x="0" y="0"/>
+          <a:ext cx="0" cy="0"/>
+          <a:chOff x="0" y="0"/>
+          <a:chExt cx="0" cy="0"/>
+        </a:xfrm>
+      </p:grpSpPr>
+      <p:sp>
+        <p:nvSpPr>
+          <p:cNvPr id="2" name="Title 1">
+            <a:extLst>
+              <a:ext uri="{FF2B5EF4-FFF2-40B4-BE49-F238E27FC236}">
                 <a16:creationId xmlns:a16="http://schemas.microsoft.com/office/drawing/2014/main" id="{44910FE7-F438-E3C9-47E9-14CDDD313E0C}"/>
               </a:ext>
             </a:extLst>
@@ -4217,7 +4866,7 @@
 </p:sld>
 </file>
 
-<file path=ppt/slides/slide8.xml><?xml version="1.0" encoding="utf-8"?>
+<file path=ppt/slides/slide9.xml><?xml version="1.0" encoding="utf-8"?>
 <p:sld xmlns:a="http://schemas.openxmlformats.org/drawingml/2006/main" xmlns:r="http://schemas.openxmlformats.org/officeDocument/2006/relationships" xmlns:p="http://schemas.openxmlformats.org/presentationml/2006/main">
   <p:cSld>
     <p:spTree>
@@ -4337,134 +4986,6 @@
     <p:extLst>
       <p:ext uri="{BB962C8B-B14F-4D97-AF65-F5344CB8AC3E}">
         <p14:creationId xmlns:p14="http://schemas.microsoft.com/office/powerpoint/2010/main" val="2849759094"/>
-      </p:ext>
-    </p:extLst>
-  </p:cSld>
-  <p:clrMapOvr>
-    <a:masterClrMapping/>
-  </p:clrMapOvr>
-</p:sld>
-</file>
-
-<file path=ppt/slides/slide9.xml><?xml version="1.0" encoding="utf-8"?>
-<p:sld xmlns:a="http://schemas.openxmlformats.org/drawingml/2006/main" xmlns:r="http://schemas.openxmlformats.org/officeDocument/2006/relationships" xmlns:p="http://schemas.openxmlformats.org/presentationml/2006/main">
-  <p:cSld>
-    <p:spTree>
-      <p:nvGrpSpPr>
-        <p:cNvPr id="1" name=""/>
-        <p:cNvGrpSpPr/>
-        <p:nvPr/>
-      </p:nvGrpSpPr>
-      <p:grpSpPr>
-        <a:xfrm>
-          <a:off x="0" y="0"/>
-          <a:ext cx="0" cy="0"/>
-          <a:chOff x="0" y="0"/>
-          <a:chExt cx="0" cy="0"/>
-        </a:xfrm>
-      </p:grpSpPr>
-      <p:sp>
-        <p:nvSpPr>
-          <p:cNvPr id="2" name="Title 1">
-            <a:extLst>
-              <a:ext uri="{FF2B5EF4-FFF2-40B4-BE49-F238E27FC236}">
-                <a16:creationId xmlns:a16="http://schemas.microsoft.com/office/drawing/2014/main" id="{71AFDFF5-7F16-36C3-CDF5-C31DC89FCA16}"/>
-              </a:ext>
-            </a:extLst>
-          </p:cNvPr>
-          <p:cNvSpPr>
-            <a:spLocks noGrp="1"/>
-          </p:cNvSpPr>
-          <p:nvPr>
-            <p:ph type="title"/>
-          </p:nvPr>
-        </p:nvSpPr>
-        <p:spPr/>
-        <p:txBody>
-          <a:bodyPr/>
-          <a:lstStyle/>
-          <a:p>
-            <a:r>
-              <a:rPr lang="en-US" dirty="0"/>
-              <a:t>Conclusions</a:t>
-            </a:r>
-          </a:p>
-        </p:txBody>
-      </p:sp>
-      <p:sp>
-        <p:nvSpPr>
-          <p:cNvPr id="3" name="Content Placeholder 2">
-            <a:extLst>
-              <a:ext uri="{FF2B5EF4-FFF2-40B4-BE49-F238E27FC236}">
-                <a16:creationId xmlns:a16="http://schemas.microsoft.com/office/drawing/2014/main" id="{078B2F5D-014F-BDDA-ADD1-E7FC12C4B8EE}"/>
-              </a:ext>
-            </a:extLst>
-          </p:cNvPr>
-          <p:cNvSpPr>
-            <a:spLocks noGrp="1"/>
-          </p:cNvSpPr>
-          <p:nvPr>
-            <p:ph idx="1"/>
-          </p:nvPr>
-        </p:nvSpPr>
-        <p:spPr>
-          <a:xfrm>
-            <a:off x="838200" y="1440873"/>
-            <a:ext cx="10515600" cy="4736090"/>
-          </a:xfrm>
-        </p:spPr>
-        <p:txBody>
-          <a:bodyPr>
-            <a:normAutofit fontScale="92500" lnSpcReduction="10000"/>
-          </a:bodyPr>
-          <a:lstStyle/>
-          <a:p>
-            <a:r>
-              <a:rPr lang="en-US" dirty="0"/>
-              <a:t>While the data provided allows us to calculate possible fines to the trash hauling company, it is difficult to make comparisons about their performance for a few reasons:</a:t>
-            </a:r>
-          </a:p>
-          <a:p>
-            <a:pPr marL="914400" lvl="1" indent="-457200">
-              <a:buFont typeface="+mj-lt"/>
-              <a:buAutoNum type="arabicPeriod"/>
-            </a:pPr>
-            <a:r>
-              <a:rPr lang="en-US" dirty="0"/>
-              <a:t>The data is based on complaints reported by residents and may not accurately map to actual missed pickups.</a:t>
-            </a:r>
-          </a:p>
-          <a:p>
-            <a:pPr marL="914400" lvl="1" indent="-457200">
-              <a:buFont typeface="+mj-lt"/>
-              <a:buAutoNum type="arabicPeriod"/>
-            </a:pPr>
-            <a:r>
-              <a:rPr lang="en-US" dirty="0"/>
-              <a:t>Incorporating information about the number of locations each route and company cover would be needed to determine the rate of missed pickups.</a:t>
-            </a:r>
-          </a:p>
-          <a:p>
-            <a:r>
-              <a:rPr lang="en-US" dirty="0"/>
-              <a:t>Further exploration to ensure trash services are available equitably could also look at differences in pickup rates by council districts, average income or home price for a neighborhood, or the day of week that pickup is scheduled for.</a:t>
-            </a:r>
-          </a:p>
-          <a:p>
-            <a:r>
-              <a:rPr lang="en-US" dirty="0"/>
-              <a:t>Finally, there may be differences within the haulers, such as salary or work culture, that impact pick-up rates, rather than details about the pick-up locations.</a:t>
-            </a:r>
-          </a:p>
-          <a:p>
-            <a:endParaRPr lang="en-US" dirty="0"/>
-          </a:p>
-        </p:txBody>
-      </p:sp>
-    </p:spTree>
-    <p:extLst>
-      <p:ext uri="{BB962C8B-B14F-4D97-AF65-F5344CB8AC3E}">
-        <p14:creationId xmlns:p14="http://schemas.microsoft.com/office/powerpoint/2010/main" val="1396121432"/>
       </p:ext>
     </p:extLst>
   </p:cSld>

</xml_diff>